<commit_message>
Clarify tutorial figures and expand the Session 2 teaching path.
Improve spatial kNN and embedding figure explanations, ease dense correlation-axis labeling, and ship the rebuilt notebooks plus shared processing helpers from the participant dry run.

Co-authored-by: Cursor <cursoragent@cursor.com>
</commit_message>
<xml_diff>
--- a/overview/eccb_2026_dgat_tutorial_slides.pptx
+++ b/overview/eccb_2026_dgat_tutorial_slides.pptx
@@ -2,122 +2,27 @@
 <file path=ppt/presentation.xml><?xml version="1.0" encoding="utf-8"?>
 <p:presentation xmlns:p="http://schemas.openxmlformats.org/presentationml/2006/main">
   <p:sldMasterIdLst>
-    <p:sldMasterId xmlns:r="http://schemas.openxmlformats.org/officeDocument/2006/relationships" id="2147483648" r:id="R820dd199f9024387"/>
+    <p:sldMasterId xmlns:r="http://schemas.openxmlformats.org/officeDocument/2006/relationships" id="2147483648" r:id="R26af2db2d7b041e4"/>
   </p:sldMasterIdLst>
   <p:notesMasterIdLst>
-    <p:notesMasterId xmlns:r="http://schemas.openxmlformats.org/officeDocument/2006/relationships" r:id="Rd40205875d204d21"/>
+    <p:notesMasterId xmlns:r="http://schemas.openxmlformats.org/officeDocument/2006/relationships" r:id="R5255eaf8bbc54a03"/>
   </p:notesMasterIdLst>
   <p:sldIdLst>
-    <p:sldId xmlns:r="http://schemas.openxmlformats.org/officeDocument/2006/relationships" id="256" r:id="Rde899261d2fd4e54"/>
-    <p:sldId xmlns:r="http://schemas.openxmlformats.org/officeDocument/2006/relationships" id="257" r:id="R3bf0230011dc4794"/>
-    <p:sldId xmlns:r="http://schemas.openxmlformats.org/officeDocument/2006/relationships" id="258" r:id="Re0229bfa31ab41b6"/>
-    <p:sldId xmlns:r="http://schemas.openxmlformats.org/officeDocument/2006/relationships" id="259" r:id="Ra7d5c31c944b41ec"/>
-    <p:sldId xmlns:r="http://schemas.openxmlformats.org/officeDocument/2006/relationships" id="260" r:id="R7b4de4c226364af7"/>
-    <p:sldId xmlns:r="http://schemas.openxmlformats.org/officeDocument/2006/relationships" id="261" r:id="R46434d6ee6604d3d"/>
-    <p:sldId xmlns:r="http://schemas.openxmlformats.org/officeDocument/2006/relationships" id="262" r:id="R190465e06b38453c"/>
-    <p:sldId xmlns:r="http://schemas.openxmlformats.org/officeDocument/2006/relationships" id="263" r:id="R480ccc1d4b0e4b0a"/>
-    <p:sldId xmlns:r="http://schemas.openxmlformats.org/officeDocument/2006/relationships" id="264" r:id="R3ff4833dfbf74247"/>
-    <p:sldId xmlns:r="http://schemas.openxmlformats.org/officeDocument/2006/relationships" id="265" r:id="Rf3c52425171f42b2"/>
-    <p:sldId xmlns:r="http://schemas.openxmlformats.org/officeDocument/2006/relationships" id="266" r:id="Ra62a7a6514364dde"/>
-    <p:sldId xmlns:r="http://schemas.openxmlformats.org/officeDocument/2006/relationships" id="267" r:id="R42a6f0b5b3ac444b"/>
+    <p:sldId xmlns:r="http://schemas.openxmlformats.org/officeDocument/2006/relationships" id="256" r:id="R9ac9af1c8a0e4180"/>
+    <p:sldId xmlns:r="http://schemas.openxmlformats.org/officeDocument/2006/relationships" id="257" r:id="R1b25516d4e254271"/>
+    <p:sldId xmlns:r="http://schemas.openxmlformats.org/officeDocument/2006/relationships" id="258" r:id="Rb52d4ff2ccce47d7"/>
+    <p:sldId xmlns:r="http://schemas.openxmlformats.org/officeDocument/2006/relationships" id="259" r:id="Rf6f34d2039f84c5c"/>
+    <p:sldId xmlns:r="http://schemas.openxmlformats.org/officeDocument/2006/relationships" id="260" r:id="R8307a792d54a4796"/>
+    <p:sldId xmlns:r="http://schemas.openxmlformats.org/officeDocument/2006/relationships" id="261" r:id="Rff9275fa9afb4c35"/>
+    <p:sldId xmlns:r="http://schemas.openxmlformats.org/officeDocument/2006/relationships" id="262" r:id="Rd83062414e514b02"/>
+    <p:sldId xmlns:r="http://schemas.openxmlformats.org/officeDocument/2006/relationships" id="263" r:id="Rfe866d7efb3d4385"/>
+    <p:sldId xmlns:r="http://schemas.openxmlformats.org/officeDocument/2006/relationships" id="264" r:id="R76d152943b1345c1"/>
+    <p:sldId xmlns:r="http://schemas.openxmlformats.org/officeDocument/2006/relationships" id="265" r:id="R5756b073445c4acd"/>
+    <p:sldId xmlns:r="http://schemas.openxmlformats.org/officeDocument/2006/relationships" id="266" r:id="Rc50a89fc3dd64d7c"/>
+    <p:sldId xmlns:r="http://schemas.openxmlformats.org/officeDocument/2006/relationships" id="267" r:id="R6587a601dbfd4405"/>
   </p:sldIdLst>
   <p:sldSz cx="12192000" cy="6858000"/>
   <p:notesSz cx="6858000" cy="9144000"/>
-  <p:defaultTextStyle>
-    <a:defPPr xmlns:a="http://schemas.openxmlformats.org/drawingml/2006/main">
-      <a:defRPr lang="en-US"/>
-    </a:defPPr>
-    <a:lvl1pPr xmlns:a="http://schemas.openxmlformats.org/drawingml/2006/main" marL="0" indent="0" algn="l" defTabSz="914400">
-      <a:defRPr sz="1800" kern="1200">
-        <a:solidFill>
-          <a:schemeClr val="tx1"/>
-        </a:solidFill>
-        <a:latin typeface="+mn-lt"/>
-        <a:ea typeface="+mn-ea"/>
-        <a:cs typeface="+mn-cs"/>
-      </a:defRPr>
-    </a:lvl1pPr>
-    <a:lvl2pPr xmlns:a="http://schemas.openxmlformats.org/drawingml/2006/main" marL="457200" indent="0" algn="l" defTabSz="914400">
-      <a:defRPr sz="1800" kern="1200">
-        <a:solidFill>
-          <a:schemeClr val="tx1"/>
-        </a:solidFill>
-        <a:latin typeface="+mn-lt"/>
-        <a:ea typeface="+mn-ea"/>
-        <a:cs typeface="+mn-cs"/>
-      </a:defRPr>
-    </a:lvl2pPr>
-    <a:lvl3pPr xmlns:a="http://schemas.openxmlformats.org/drawingml/2006/main" marL="914400" indent="0" algn="l" defTabSz="914400">
-      <a:defRPr sz="1800" kern="1200">
-        <a:solidFill>
-          <a:schemeClr val="tx1"/>
-        </a:solidFill>
-        <a:latin typeface="+mn-lt"/>
-        <a:ea typeface="+mn-ea"/>
-        <a:cs typeface="+mn-cs"/>
-      </a:defRPr>
-    </a:lvl3pPr>
-    <a:lvl4pPr xmlns:a="http://schemas.openxmlformats.org/drawingml/2006/main" marL="1371600" indent="0" algn="l" defTabSz="914400">
-      <a:defRPr sz="1800" kern="1200">
-        <a:solidFill>
-          <a:schemeClr val="tx1"/>
-        </a:solidFill>
-        <a:latin typeface="+mn-lt"/>
-        <a:ea typeface="+mn-ea"/>
-        <a:cs typeface="+mn-cs"/>
-      </a:defRPr>
-    </a:lvl4pPr>
-    <a:lvl5pPr xmlns:a="http://schemas.openxmlformats.org/drawingml/2006/main" marL="1828800" indent="0" algn="l" defTabSz="914400">
-      <a:defRPr sz="1800" kern="1200">
-        <a:solidFill>
-          <a:schemeClr val="tx1"/>
-        </a:solidFill>
-        <a:latin typeface="+mn-lt"/>
-        <a:ea typeface="+mn-ea"/>
-        <a:cs typeface="+mn-cs"/>
-      </a:defRPr>
-    </a:lvl5pPr>
-    <a:lvl6pPr xmlns:a="http://schemas.openxmlformats.org/drawingml/2006/main" marL="2286000" indent="0" algn="l" defTabSz="914400">
-      <a:defRPr sz="1800" kern="1200">
-        <a:solidFill>
-          <a:schemeClr val="tx1"/>
-        </a:solidFill>
-        <a:latin typeface="+mn-lt"/>
-        <a:ea typeface="+mn-ea"/>
-        <a:cs typeface="+mn-cs"/>
-      </a:defRPr>
-    </a:lvl6pPr>
-    <a:lvl7pPr xmlns:a="http://schemas.openxmlformats.org/drawingml/2006/main" marL="2743200" indent="0" algn="l" defTabSz="914400">
-      <a:defRPr sz="1800" kern="1200">
-        <a:solidFill>
-          <a:schemeClr val="tx1"/>
-        </a:solidFill>
-        <a:latin typeface="+mn-lt"/>
-        <a:ea typeface="+mn-ea"/>
-        <a:cs typeface="+mn-cs"/>
-      </a:defRPr>
-    </a:lvl7pPr>
-    <a:lvl8pPr xmlns:a="http://schemas.openxmlformats.org/drawingml/2006/main" marL="3200400" indent="0" algn="l" defTabSz="914400">
-      <a:defRPr sz="1800" kern="1200">
-        <a:solidFill>
-          <a:schemeClr val="tx1"/>
-        </a:solidFill>
-        <a:latin typeface="+mn-lt"/>
-        <a:ea typeface="+mn-ea"/>
-        <a:cs typeface="+mn-cs"/>
-      </a:defRPr>
-    </a:lvl8pPr>
-    <a:lvl9pPr xmlns:a="http://schemas.openxmlformats.org/drawingml/2006/main" marL="3657600" indent="0" algn="l" defTabSz="914400">
-      <a:defRPr sz="1800" kern="1200">
-        <a:solidFill>
-          <a:schemeClr val="tx1"/>
-        </a:solidFill>
-        <a:latin typeface="+mn-lt"/>
-        <a:ea typeface="+mn-ea"/>
-        <a:cs typeface="+mn-cs"/>
-      </a:defRPr>
-    </a:lvl9pPr>
-  </p:defaultTextStyle>
 </p:presentation>
 </file>
 
@@ -1338,7 +1243,7 @@
   </p:cSld>
   <p:clrMap bg1="lt1" tx1="dk1" bg2="lt2" tx2="dk2" accent1="accent1" accent2="accent2" accent3="accent3" accent4="accent4" accent5="accent5" accent6="accent6" hlink="hlink" folHlink="folHlink"/>
   <p:sldLayoutIdLst>
-    <p:sldLayoutId xmlns:r="http://schemas.openxmlformats.org/officeDocument/2006/relationships" id="2147483649" r:id="Re829bc60da9a4f7e"/>
+    <p:sldLayoutId xmlns:r="http://schemas.openxmlformats.org/officeDocument/2006/relationships" id="2147483649" r:id="R3ec0d30112644190"/>
   </p:sldLayoutIdLst>
   <p:txStyles>
     <p:titleStyle>
@@ -2419,7 +2324,7 @@
       </p:sp>
       <p:cxnSp>
         <p:nvCxnSpPr>
-          <p:cNvPr id="33" name="rule"/>
+          <p:cNvPr id="49" name="rule"/>
           <p:cNvCxnSpPr/>
           <p:nvPr/>
         </p:nvCxnSpPr>
@@ -2565,7 +2470,7 @@
                   <a:srgbClr val="555555"/>
                 </a:solidFill>
               </a:rPr>
-              <a:t>Backup plan</a:t>
+              <a:t>Live contingency</a:t>
             </a:r>
           </a:p>
         </p:txBody>
@@ -2616,7 +2521,7 @@
                   <a:srgbClr val="000000"/>
                 </a:solidFill>
               </a:rPr>
-              <a:t>Make the live session independent of Wi-Fi</a:t>
+              <a:t>Keep instructor-led setup resilient</a:t>
             </a:r>
           </a:p>
         </p:txBody>
@@ -2718,7 +2623,7 @@
                   <a:srgbClr val="000000"/>
                 </a:solidFill>
               </a:rPr>
-              <a:t>Participant path</a:t>
+              <a:t>Participants</a:t>
             </a:r>
           </a:p>
         </p:txBody>
@@ -2769,15 +2674,25 @@
                   <a:srgbClr val="000000"/>
                 </a:solidFill>
               </a:rPr>
-              <a:t>• </a:t>
-            </a:r>
+              <a:t>• Clone repository in class</a:t>
+            </a:r>
+          </a:p>
+          <a:p xmlns:a="http://schemas.openxmlformats.org/drawingml/2006/main">
+            <a:pPr algn="l">
+              <a:buNone/>
+              <a:defRPr sz="1800" b="0">
+                <a:solidFill>
+                  <a:srgbClr val="000000"/>
+                </a:solidFill>
+              </a:defRPr>
+            </a:pPr>
             <a:r>
               <a:rPr sz="1800" b="0">
                 <a:solidFill>
                   <a:srgbClr val="000000"/>
                 </a:solidFill>
               </a:rPr>
-              <a:t>Data downloaded ≥24 h early</a:t>
+              <a:t>• Create the Python 3.10 environment</a:t>
             </a:r>
           </a:p>
           <a:p xmlns:a="http://schemas.openxmlformats.org/drawingml/2006/main">
@@ -2795,41 +2710,7 @@
                   <a:srgbClr val="000000"/>
                 </a:solidFill>
               </a:rPr>
-              <a:t>• </a:t>
-            </a:r>
-            <a:r>
-              <a:rPr sz="1800" b="0">
-                <a:solidFill>
-                  <a:srgbClr val="000000"/>
-                </a:solidFill>
-              </a:rPr>
-              <a:t>Precomputed DGAT predictions present</a:t>
-            </a:r>
-          </a:p>
-          <a:p xmlns:a="http://schemas.openxmlformats.org/drawingml/2006/main">
-            <a:pPr algn="l">
-              <a:buNone/>
-              <a:defRPr sz="1800" b="0">
-                <a:solidFill>
-                  <a:srgbClr val="000000"/>
-                </a:solidFill>
-              </a:defRPr>
-            </a:pPr>
-            <a:r>
-              <a:rPr sz="1800" b="0">
-                <a:solidFill>
-                  <a:srgbClr val="000000"/>
-                </a:solidFill>
-              </a:rPr>
-              <a:t>• </a:t>
-            </a:r>
-            <a:r>
-              <a:rPr sz="1800" b="0">
-                <a:solidFill>
-                  <a:srgbClr val="000000"/>
-                </a:solidFill>
-              </a:rPr>
-              <a:t>Python 3.10 notebooks tested</a:t>
+              <a:t>• Download, verify, and prepare data</a:t>
             </a:r>
           </a:p>
         </p:txBody>
@@ -2880,7 +2761,7 @@
                   <a:srgbClr val="FF6B35"/>
                 </a:solidFill>
               </a:rPr>
-              <a:t>Organizer path</a:t>
+              <a:t>Organizer backup</a:t>
             </a:r>
           </a:p>
         </p:txBody>
@@ -2931,15 +2812,25 @@
                   <a:srgbClr val="000000"/>
                 </a:solidFill>
               </a:rPr>
-              <a:t>• </a:t>
-            </a:r>
+              <a:t>• Local repository mirror available</a:t>
+            </a:r>
+          </a:p>
+          <a:p xmlns:a="http://schemas.openxmlformats.org/drawingml/2006/main">
+            <a:pPr algn="l">
+              <a:buNone/>
+              <a:defRPr sz="1800" b="0">
+                <a:solidFill>
+                  <a:srgbClr val="000000"/>
+                </a:solidFill>
+              </a:defRPr>
+            </a:pPr>
             <a:r>
               <a:rPr sz="1800" b="0">
                 <a:solidFill>
                   <a:srgbClr val="000000"/>
                 </a:solidFill>
               </a:rPr>
-              <a:t>Python 3.11 DGAT environment</a:t>
+              <a:t>• Conda package cache available</a:t>
             </a:r>
           </a:p>
           <a:p xmlns:a="http://schemas.openxmlformats.org/drawingml/2006/main">
@@ -2957,41 +2848,7 @@
                   <a:srgbClr val="000000"/>
                 </a:solidFill>
               </a:rPr>
-              <a:t>• </a:t>
-            </a:r>
-            <a:r>
-              <a:rPr sz="1800" b="0">
-                <a:solidFill>
-                  <a:srgbClr val="000000"/>
-                </a:solidFill>
-              </a:rPr>
-              <a:t>GPU/HPC arranged and preflighted</a:t>
-            </a:r>
-          </a:p>
-          <a:p xmlns:a="http://schemas.openxmlformats.org/drawingml/2006/main">
-            <a:pPr algn="l">
-              <a:buNone/>
-              <a:defRPr sz="1800" b="0">
-                <a:solidFill>
-                  <a:srgbClr val="000000"/>
-                </a:solidFill>
-              </a:defRPr>
-            </a:pPr>
-            <a:r>
-              <a:rPr sz="1800" b="0">
-                <a:solidFill>
-                  <a:srgbClr val="000000"/>
-                </a:solidFill>
-              </a:rPr>
-              <a:t>• </a:t>
-            </a:r>
-            <a:r>
-              <a:rPr sz="1800" b="0">
-                <a:solidFill>
-                  <a:srgbClr val="000000"/>
-                </a:solidFill>
-              </a:rPr>
-              <a:t>Official inference run before class</a:t>
+              <a:t>• Breast data mirror available</a:t>
             </a:r>
           </a:p>
         </p:txBody>
@@ -3073,14 +2930,14 @@
                   <a:srgbClr val="000000"/>
                 </a:solidFill>
               </a:rPr>
-              <a:t>A missing prediction table stops clearly—it never triggers a silent fitted baseline.</a:t>
+              <a:t>Contingencies protect the live workflow; they do not replace participant setup or data preparation.</a:t>
             </a:r>
           </a:p>
         </p:txBody>
       </p:sp>
       <p:cxnSp>
         <p:nvCxnSpPr>
-          <p:cNvPr id="41" name="rule"/>
+          <p:cNvPr id="61" name="rule"/>
           <p:cNvCxnSpPr/>
           <p:nvPr/>
         </p:nvCxnSpPr>
@@ -3277,7 +3134,7 @@
                   <a:srgbClr val="000000"/>
                 </a:solidFill>
               </a:rPr>
-              <a:t>Before release: readiness gates</a:t>
+              <a:t>Live-session readiness gates</a:t>
             </a:r>
           </a:p>
         </p:txBody>
@@ -3335,7 +3192,7 @@
       </p:sp>
       <p:graphicFrame>
         <p:nvGraphicFramePr>
-          <p:cNvPr id="25" name=""/>
+          <p:cNvPr id="39" name=""/>
           <p:cNvGraphicFramePr/>
           <p:nvPr/>
         </p:nvGraphicFramePr>
@@ -3424,7 +3281,7 @@
                             <a:srgbClr val="000000"/>
                           </a:solidFill>
                         </a:rPr>
-                        <a:t>Data + predictions sent ≥1 week early</a:t>
+                        <a:t>Tutorial-network download and checksum timed</a:t>
                       </a:r>
                     </a:p>
                   </a:txBody>
@@ -3443,7 +3300,7 @@
                             <a:srgbClr val="000000"/>
                           </a:solidFill>
                         </a:rPr>
-                        <a:t>Model</a:t>
+                        <a:t>Environment</a:t>
                       </a:r>
                     </a:p>
                   </a:txBody>
@@ -3460,7 +3317,7 @@
                             <a:srgbClr val="000000"/>
                           </a:solidFill>
                         </a:rPr>
-                        <a:t>Python 3.11 DGAT env passes preflight</a:t>
+                        <a:t>Clean Python 3.10 creation tested</a:t>
                       </a:r>
                     </a:p>
                   </a:txBody>
@@ -3496,7 +3353,7 @@
                             <a:srgbClr val="000000"/>
                           </a:solidFill>
                         </a:rPr>
-                        <a:t>Python 3.10 path runs clean; default is DGAT output</a:t>
+                        <a:t>Setup → QC → DGAT → evaluation runs clean</a:t>
                       </a:r>
                     </a:p>
                   </a:txBody>
@@ -3515,7 +3372,7 @@
                             <a:srgbClr val="000000"/>
                           </a:solidFill>
                         </a:rPr>
-                        <a:t>Backup</a:t>
+                        <a:t>Contingency</a:t>
                       </a:r>
                     </a:p>
                   </a:txBody>
@@ -3532,7 +3389,7 @@
                             <a:srgbClr val="000000"/>
                           </a:solidFill>
                         </a:rPr>
-                        <a:t>Provenance retained; ridge labeled baseline</a:t>
+                        <a:t>Local repository, package, and data mirrors ready</a:t>
                       </a:r>
                     </a:p>
                   </a:txBody>
@@ -3625,14 +3482,14 @@
                   <a:srgbClr val="000000"/>
                 </a:solidFill>
               </a:rPr>
-              <a:t>Deliverable: setup completed before travel and results participants can interpret honestly.</a:t>
+              <a:t>Deliverable: participants perform setup, data preparation, DGAT modeling, and evaluation during class.</a:t>
             </a:r>
           </a:p>
         </p:txBody>
       </p:sp>
       <p:cxnSp>
         <p:nvCxnSpPr>
-          <p:cNvPr id="27" name="rule"/>
+          <p:cNvPr id="41" name="rule"/>
           <p:cNvCxnSpPr/>
           <p:nvPr/>
         </p:nvCxnSpPr>
@@ -4253,7 +4110,7 @@
       </p:sp>
       <p:graphicFrame>
         <p:nvGraphicFramePr>
-          <p:cNvPr id="25" name=""/>
+          <p:cNvPr id="39" name=""/>
           <p:cNvGraphicFramePr/>
           <p:nvPr/>
         </p:nvGraphicFramePr>
@@ -4347,7 +4204,7 @@
                             <a:srgbClr val="000000"/>
                           </a:solidFill>
                         </a:rPr>
-                        <a:t>10:45–11:05</a:t>
+                        <a:t>10:45–11:15</a:t>
                       </a:r>
                     </a:p>
                   </a:txBody>
@@ -4364,7 +4221,7 @@
                             <a:srgbClr val="000000"/>
                           </a:solidFill>
                         </a:rPr>
-                        <a:t>Environment setup and spatial data exploration</a:t>
+                        <a:t>Live setup and data processing</a:t>
                       </a:r>
                     </a:p>
                   </a:txBody>
@@ -4381,7 +4238,7 @@
                             <a:srgbClr val="000000"/>
                           </a:solidFill>
                         </a:rPr>
-                        <a:t>Load DGAT data, inspect coordinates, visualize transcript/protein signals.</a:t>
+                        <a:t>Create env, download and verify data, then QC and normalize both modalities.</a:t>
                       </a:r>
                     </a:p>
                   </a:txBody>
@@ -4400,7 +4257,7 @@
                             <a:srgbClr val="000000"/>
                           </a:solidFill>
                         </a:rPr>
-                        <a:t>11:05–11:35</a:t>
+                        <a:t>11:15–11:40</a:t>
                       </a:r>
                     </a:p>
                   </a:txBody>
@@ -4417,7 +4274,7 @@
                             <a:srgbClr val="000000"/>
                           </a:solidFill>
                         </a:rPr>
-                        <a:t>Using DGAT protein inference outputs</a:t>
+                        <a:t>Build, train, and run DGAT</a:t>
                       </a:r>
                     </a:p>
                   </a:txBody>
@@ -4434,7 +4291,7 @@
                             <a:srgbClr val="000000"/>
                           </a:solidFill>
                         </a:rPr>
-                        <a:t>Align inputs, load official DGAT predictions, generate spatial protein maps.</a:t>
+                        <a:t>Construct four modules, trace five-loss training, and run verified inference.</a:t>
                       </a:r>
                     </a:p>
                   </a:txBody>
@@ -4453,7 +4310,7 @@
                             <a:srgbClr val="000000"/>
                           </a:solidFill>
                         </a:rPr>
-                        <a:t>11:35–12:00</a:t>
+                        <a:t>11:40–12:00</a:t>
                       </a:r>
                     </a:p>
                   </a:txBody>
@@ -4487,7 +4344,7 @@
                             <a:srgbClr val="000000"/>
                           </a:solidFill>
                         </a:rPr>
-                        <a:t>Correlation metrics, Moran's I, landscape comparison, and pitfalls.</a:t>
+                        <a:t>Correlation, Moran's I, residual maps, and inferred-protein structure.</a:t>
                       </a:r>
                     </a:p>
                   </a:txBody>
@@ -4544,14 +4401,14 @@
                   <a:srgbClr val="000000"/>
                 </a:solidFill>
               </a:rPr>
-              <a:t>Default live path: load organizer-provided DGAT predictions; run official inference before class.</a:t>
+              <a:t>Live path: participants create the environment, download data, and prepare model inputs during class.</a:t>
             </a:r>
           </a:p>
         </p:txBody>
       </p:sp>
       <p:cxnSp>
         <p:nvCxnSpPr>
-          <p:cNvPr id="27" name="rule"/>
+          <p:cNvPr id="41" name="rule"/>
           <p:cNvCxnSpPr/>
           <p:nvPr/>
         </p:nvCxnSpPr>
@@ -4908,7 +4765,7 @@
       </p:sp>
       <p:cxnSp>
         <p:nvCxnSpPr>
-          <p:cNvPr id="67" name="rule"/>
+          <p:cNvPr id="107" name="rule"/>
           <p:cNvCxnSpPr/>
           <p:nvPr/>
         </p:nvCxnSpPr>
@@ -5032,7 +4889,7 @@
       </p:sp>
       <p:cxnSp>
         <p:nvCxnSpPr>
-          <p:cNvPr id="70" name="rule"/>
+          <p:cNvPr id="110" name="rule"/>
           <p:cNvCxnSpPr/>
           <p:nvPr/>
         </p:nvCxnSpPr>
@@ -5156,7 +5013,7 @@
       </p:sp>
       <p:cxnSp>
         <p:nvCxnSpPr>
-          <p:cNvPr id="73" name="rule"/>
+          <p:cNvPr id="113" name="rule"/>
           <p:cNvCxnSpPr/>
           <p:nvPr/>
         </p:nvCxnSpPr>
@@ -5280,7 +5137,7 @@
       </p:sp>
       <p:cxnSp>
         <p:nvCxnSpPr>
-          <p:cNvPr id="76" name="rule"/>
+          <p:cNvPr id="116" name="rule"/>
           <p:cNvCxnSpPr/>
           <p:nvPr/>
         </p:nvCxnSpPr>
@@ -5404,7 +5261,7 @@
       </p:sp>
       <p:cxnSp>
         <p:nvCxnSpPr>
-          <p:cNvPr id="79" name="rule"/>
+          <p:cNvPr id="119" name="rule"/>
           <p:cNvCxnSpPr/>
           <p:nvPr/>
         </p:nvCxnSpPr>
@@ -5457,7 +5314,7 @@
       </p:sp>
       <p:cxnSp>
         <p:nvCxnSpPr>
-          <p:cNvPr id="81" name="rule"/>
+          <p:cNvPr id="121" name="rule"/>
           <p:cNvCxnSpPr/>
           <p:nvPr/>
         </p:nvCxnSpPr>
@@ -5654,7 +5511,7 @@
                   <a:srgbClr val="000000"/>
                 </a:solidFill>
               </a:rPr>
-              <a:t>Complete setup before the conference</a:t>
+              <a:t>Build the workflow together in class</a:t>
             </a:r>
           </a:p>
         </p:txBody>
@@ -5838,7 +5695,7 @@
                   <a:srgbClr val="000000"/>
                 </a:solidFill>
               </a:rPr>
-              <a:t>Create tutorial env</a:t>
+              <a:t>Clone repository</a:t>
             </a:r>
           </a:p>
         </p:txBody>
@@ -5889,8 +5746,25 @@
                   <a:srgbClr val="555555"/>
                 </a:solidFill>
               </a:rPr>
-              <a:t>Python 3.10
-16 GB RAM recommended</a:t>
+              <a:t>Inspect layout</a:t>
+            </a:r>
+          </a:p>
+          <a:p xmlns:a="http://schemas.openxmlformats.org/drawingml/2006/main">
+            <a:pPr algn="l">
+              <a:buNone/>
+              <a:defRPr sz="1350" b="0">
+                <a:solidFill>
+                  <a:srgbClr val="555555"/>
+                </a:solidFill>
+              </a:defRPr>
+            </a:pPr>
+            <a:r>
+              <a:rPr sz="1350" b="0">
+                <a:solidFill>
+                  <a:srgbClr val="555555"/>
+                </a:solidFill>
+              </a:rPr>
+              <a:t>enter tutorial root</a:t>
             </a:r>
           </a:p>
         </p:txBody>
@@ -6023,7 +5897,7 @@
                   <a:srgbClr val="000000"/>
                 </a:solidFill>
               </a:rPr>
-              <a:t>Download data</a:t>
+              <a:t>Create environment</a:t>
             </a:r>
           </a:p>
         </p:txBody>
@@ -6074,7 +5948,7 @@
                   <a:srgbClr val="555555"/>
                 </a:solidFill>
               </a:rPr>
-              <a:t>Run ≥24 h early</a:t>
+              <a:t>Conda + Python 3.10</a:t>
             </a:r>
           </a:p>
           <a:p xmlns:a="http://schemas.openxmlformats.org/drawingml/2006/main">
@@ -6092,7 +5966,7 @@
                   <a:srgbClr val="555555"/>
                 </a:solidFill>
               </a:rPr>
-              <a:t>~15 min in review</a:t>
+              <a:t>select kernel</a:t>
             </a:r>
           </a:p>
         </p:txBody>
@@ -6225,7 +6099,7 @@
                   <a:srgbClr val="000000"/>
                 </a:solidFill>
               </a:rPr>
-              <a:t>Add predictions</a:t>
+              <a:t>Download data</a:t>
             </a:r>
           </a:p>
         </p:txBody>
@@ -6276,8 +6150,25 @@
                   <a:srgbClr val="555555"/>
                 </a:solidFill>
               </a:rPr>
-              <a:t>data/raw/
-dgat_predictions.csv</a:t>
+              <a:t>Breast RNA + ADT</a:t>
+            </a:r>
+          </a:p>
+          <a:p xmlns:a="http://schemas.openxmlformats.org/drawingml/2006/main">
+            <a:pPr algn="l">
+              <a:buNone/>
+              <a:defRPr sz="1350" b="0">
+                <a:solidFill>
+                  <a:srgbClr val="555555"/>
+                </a:solidFill>
+              </a:defRPr>
+            </a:pPr>
+            <a:r>
+              <a:rPr sz="1350" b="0">
+                <a:solidFill>
+                  <a:srgbClr val="555555"/>
+                </a:solidFill>
+              </a:rPr>
+              <a:t>verify provenance</a:t>
             </a:r>
           </a:p>
         </p:txBody>
@@ -6410,7 +6301,7 @@
                   <a:srgbClr val="000000"/>
                 </a:solidFill>
               </a:rPr>
-              <a:t>Run notebooks</a:t>
+              <a:t>Prepare inputs</a:t>
             </a:r>
           </a:p>
         </p:txBody>
@@ -6461,7 +6352,25 @@
                   <a:srgbClr val="555555"/>
                 </a:solidFill>
               </a:rPr>
-              <a:t>notebooks/01 → 02 → 03</a:t>
+              <a:t>QC + normalize</a:t>
+            </a:r>
+          </a:p>
+          <a:p xmlns:a="http://schemas.openxmlformats.org/drawingml/2006/main">
+            <a:pPr algn="l">
+              <a:buNone/>
+              <a:defRPr sz="1350" b="0">
+                <a:solidFill>
+                  <a:srgbClr val="555555"/>
+                </a:solidFill>
+              </a:defRPr>
+            </a:pPr>
+            <a:r>
+              <a:rPr sz="1350" b="0">
+                <a:solidFill>
+                  <a:srgbClr val="555555"/>
+                </a:solidFill>
+              </a:rPr>
+              <a:t>build spatial graph</a:t>
             </a:r>
           </a:p>
         </p:txBody>
@@ -6512,14 +6421,14 @@
                   <a:srgbClr val="000000"/>
                 </a:solidFill>
               </a:rPr>
-              <a:t>Official inference uses a separate Python 3.11 environment; prepare it before class or on HPC.</a:t>
+              <a:t>The instructor pauses at each checkpoint; no environment or dataset preparation is required before class.</a:t>
             </a:r>
           </a:p>
         </p:txBody>
       </p:sp>
       <p:cxnSp>
         <p:nvCxnSpPr>
-          <p:cNvPr id="85" name="rule"/>
+          <p:cNvPr id="127" name="rule"/>
           <p:cNvCxnSpPr/>
           <p:nvPr/>
         </p:nvCxnSpPr>
@@ -7044,7 +6953,7 @@
       </p:sp>
       <p:graphicFrame>
         <p:nvGraphicFramePr>
-          <p:cNvPr id="41" name=""/>
+          <p:cNvPr id="63" name=""/>
           <p:cNvGraphicFramePr/>
           <p:nvPr/>
         </p:nvGraphicFramePr>
@@ -7415,7 +7324,7 @@
       </p:sp>
       <p:cxnSp>
         <p:nvCxnSpPr>
-          <p:cNvPr id="43" name="rule"/>
+          <p:cNvPr id="65" name="rule"/>
           <p:cNvCxnSpPr/>
           <p:nvPr/>
         </p:nvCxnSpPr>
@@ -7612,7 +7521,7 @@
                   <a:srgbClr val="000000"/>
                 </a:solidFill>
               </a:rPr>
-              <a:t>Session 1: make the spatial data tangible</a:t>
+              <a:t>Session 1: prepare and explore the data</a:t>
             </a:r>
           </a:p>
         </p:txBody>
@@ -8075,7 +7984,7 @@
                   <a:srgbClr val="000000"/>
                 </a:solidFill>
               </a:rPr>
-              <a:t>• Confirm the kernel and paths</a:t>
+              <a:t>• Validate paired RNA, ADT, and coordinates</a:t>
             </a:r>
           </a:p>
           <a:p xmlns:a="http://schemas.openxmlformats.org/drawingml/2006/main">
@@ -8093,15 +8002,25 @@
                   <a:srgbClr val="000000"/>
                 </a:solidFill>
               </a:rPr>
-              <a:t>• </a:t>
-            </a:r>
+              <a:t>• Plot modality-specific QC distributions</a:t>
+            </a:r>
+          </a:p>
+          <a:p xmlns:a="http://schemas.openxmlformats.org/drawingml/2006/main">
+            <a:pPr algn="l">
+              <a:buNone/>
+              <a:defRPr sz="2025" b="0">
+                <a:solidFill>
+                  <a:srgbClr val="000000"/>
+                </a:solidFill>
+              </a:defRPr>
+            </a:pPr>
             <a:r>
               <a:rPr sz="2025" b="0">
                 <a:solidFill>
                   <a:srgbClr val="000000"/>
                 </a:solidFill>
               </a:rPr>
-              <a:t>Load official DGAT .h5ad data</a:t>
+              <a:t>• Filter low-quality spots and features</a:t>
             </a:r>
           </a:p>
           <a:p xmlns:a="http://schemas.openxmlformats.org/drawingml/2006/main">
@@ -8119,7 +8038,7 @@
                   <a:srgbClr val="000000"/>
                 </a:solidFill>
               </a:rPr>
-              <a:t>• Plot transcripts and observed proteins</a:t>
+              <a:t>• Normalize RNA and protein explicitly</a:t>
             </a:r>
           </a:p>
           <a:p xmlns:a="http://schemas.openxmlformats.org/drawingml/2006/main">
@@ -8137,7 +8056,7 @@
                   <a:srgbClr val="000000"/>
                 </a:solidFill>
               </a:rPr>
-              <a:t>• Inspect nearest-neighbor structure</a:t>
+              <a:t>• Build and inspect the spatial kNN graph</a:t>
             </a:r>
           </a:p>
         </p:txBody>
@@ -8188,14 +8107,14 @@
                   <a:srgbClr val="555555"/>
                 </a:solidFill>
               </a:rPr>
-              <a:t>Output: participants understand what each matrix represents before model inference.</a:t>
+              <a:t>Output: participants can explain every processing decision before model construction.</a:t>
             </a:r>
           </a:p>
         </p:txBody>
       </p:sp>
       <p:cxnSp>
         <p:nvCxnSpPr>
-          <p:cNvPr id="69" name="rule"/>
+          <p:cNvPr id="103" name="rule"/>
           <p:cNvCxnSpPr/>
           <p:nvPr/>
         </p:nvCxnSpPr>
@@ -8392,7 +8311,7 @@
                   <a:srgbClr val="000000"/>
                 </a:solidFill>
               </a:rPr>
-              <a:t>Session 2: precomputed DGAT, no leakage</a:t>
+              <a:t>Session 2: build and train DGAT</a:t>
             </a:r>
           </a:p>
         </p:txBody>
@@ -8525,7 +8444,7 @@
                   <a:srgbClr val="000000"/>
                 </a:solidFill>
               </a:rPr>
-              <a:t>Align</a:t>
+              <a:t>Graphs</a:t>
             </a:r>
           </a:p>
         </p:txBody>
@@ -8576,14 +8495,14 @@
                   <a:srgbClr val="555555"/>
                 </a:solidFill>
               </a:rPr>
-              <a:t>spots, transcripts, proteins</a:t>
+              <a:t>RNA + protein inputs</a:t>
             </a:r>
           </a:p>
         </p:txBody>
       </p:sp>
       <p:cxnSp>
         <p:nvCxnSpPr>
-          <p:cNvPr id="71" name="rule"/>
+          <p:cNvPr id="113" name="rule"/>
           <p:cNvCxnSpPr/>
           <p:nvPr/>
         </p:nvCxnSpPr>
@@ -8680,7 +8599,7 @@
                   <a:srgbClr val="000000"/>
                 </a:solidFill>
               </a:rPr>
-              <a:t>Prepare</a:t>
+              <a:t>Build</a:t>
             </a:r>
           </a:p>
         </p:txBody>
@@ -8731,14 +8650,14 @@
                   <a:srgbClr val="555555"/>
                 </a:solidFill>
               </a:rPr>
-              <a:t>model-ready input</a:t>
+              <a:t>four model modules</a:t>
             </a:r>
           </a:p>
         </p:txBody>
       </p:sp>
       <p:cxnSp>
         <p:nvCxnSpPr>
-          <p:cNvPr id="75" name="rule"/>
+          <p:cNvPr id="117" name="rule"/>
           <p:cNvCxnSpPr/>
           <p:nvPr/>
         </p:nvCxnSpPr>
@@ -8835,7 +8754,7 @@
                   <a:srgbClr val="FF6B35"/>
                 </a:solidFill>
               </a:rPr>
-              <a:t>Infer</a:t>
+              <a:t>Train</a:t>
             </a:r>
           </a:p>
         </p:txBody>
@@ -8886,14 +8805,14 @@
                   <a:srgbClr val="555555"/>
                 </a:solidFill>
               </a:rPr>
-              <a:t>precomputed DGAT output</a:t>
+              <a:t>five-loss objective</a:t>
             </a:r>
           </a:p>
         </p:txBody>
       </p:sp>
       <p:cxnSp>
         <p:nvCxnSpPr>
-          <p:cNvPr id="79" name="rule"/>
+          <p:cNvPr id="121" name="rule"/>
           <p:cNvCxnSpPr/>
           <p:nvPr/>
         </p:nvCxnSpPr>
@@ -8990,7 +8909,7 @@
                   <a:srgbClr val="000000"/>
                 </a:solidFill>
               </a:rPr>
-              <a:t>Visualize</a:t>
+              <a:t>Infer</a:t>
             </a:r>
           </a:p>
         </p:txBody>
@@ -9041,7 +8960,7 @@
                   <a:srgbClr val="555555"/>
                 </a:solidFill>
               </a:rPr>
-              <a:t>predicted protein maps</a:t>
+              <a:t>RNA → protein maps</a:t>
             </a:r>
           </a:p>
         </p:txBody>
@@ -9092,7 +9011,7 @@
                   <a:srgbClr val="000000"/>
                 </a:solidFill>
               </a:rPr>
-              <a:t>Teaching tactic</a:t>
+              <a:t>Learning path</a:t>
             </a:r>
           </a:p>
         </p:txBody>
@@ -9143,14 +9062,14 @@
                   <a:srgbClr val="555555"/>
                 </a:solidFill>
               </a:rPr>
-              <a:t>Default: load official DGAT output. The optional ridge baseline is out-of-fold, clearly labeled, and not DGAT.</a:t>
+              <a:t>Construct the encoders and decoders, trace one optimization step, then connect saved weights to verified inference.</a:t>
             </a:r>
           </a:p>
         </p:txBody>
       </p:sp>
       <p:cxnSp>
         <p:nvCxnSpPr>
-          <p:cNvPr id="85" name="rule"/>
+          <p:cNvPr id="127" name="rule"/>
           <p:cNvCxnSpPr/>
           <p:nvPr/>
         </p:nvCxnSpPr>
@@ -9405,7 +9324,7 @@
       </p:sp>
       <p:graphicFrame>
         <p:nvGraphicFramePr>
-          <p:cNvPr id="40" name="Chart"/>
+          <p:cNvPr id="64" name="Chart"/>
           <p:cNvGraphicFramePr/>
           <p:nvPr/>
         </p:nvGraphicFramePr>
@@ -9415,7 +9334,7 @@
         </p:xfrm>
         <a:graphic xmlns:a="http://schemas.openxmlformats.org/drawingml/2006/main">
           <a:graphicData uri="http://schemas.openxmlformats.org/drawingml/2006/chart">
-            <c:chart xmlns:r="http://schemas.openxmlformats.org/officeDocument/2006/relationships" xmlns:c="http://schemas.openxmlformats.org/drawingml/2006/chart" r:id="Rbb8e0f70fb614150"/>
+            <c:chart xmlns:r="http://schemas.openxmlformats.org/officeDocument/2006/relationships" xmlns:c="http://schemas.openxmlformats.org/drawingml/2006/chart" r:id="R36517ebd0e9040a8"/>
           </a:graphicData>
         </a:graphic>
       </p:graphicFrame>
@@ -9656,7 +9575,7 @@
       </p:sp>
       <p:cxnSp>
         <p:nvCxnSpPr>
-          <p:cNvPr id="46" name="rule"/>
+          <p:cNvPr id="70" name="rule"/>
           <p:cNvCxnSpPr/>
           <p:nvPr/>
         </p:nvCxnSpPr>
@@ -9678,7 +9597,7 @@
       </p:cxnSp>
       <p:cxnSp>
         <p:nvCxnSpPr>
-          <p:cNvPr id="47" name="rule"/>
+          <p:cNvPr id="71" name="rule"/>
           <p:cNvCxnSpPr/>
           <p:nvPr/>
         </p:nvCxnSpPr>
@@ -10465,7 +10384,7 @@
       </p:sp>
       <p:cxnSp>
         <p:nvCxnSpPr>
-          <p:cNvPr id="65" name="rule"/>
+          <p:cNvPr id="97" name="rule"/>
           <p:cNvCxnSpPr/>
           <p:nvPr/>
         </p:nvCxnSpPr>

</xml_diff>